<commit_message>
Replace Momly with Swasth across design PDF, reference assets and code; remove all Hindi text
</commit_message>
<xml_diff>
--- a/deck/Swasth_App_Design_5_Slides.pptx
+++ b/deck/Swasth_App_Design_5_Slides.pptx
@@ -3167,7 +3167,7 @@
               </a:defRPr>
             </a:pPr>
             <a:r>
-              <a:t>SWASTH (मातृ-स्वास्थ्य)</a:t>
+              <a:t>SWASTH (Maternal Health)</a:t>
             </a:r>
           </a:p>
           <a:p>
@@ -3235,7 +3235,7 @@
       </p:sp>
       <p:pic>
         <p:nvPicPr>
-          <p:cNvPr id="4" name="Picture 3" descr="15_momly_hero_mockup.png"/>
+          <p:cNvPr id="4" name="Picture 3" descr="15_swasth_hero_mockup.png"/>
           <p:cNvPicPr>
             <a:picLocks noChangeAspect="1"/>
           </p:cNvPicPr>

</xml_diff>

<commit_message>
Replace all reference images in pitch deck with native Swasth app screenshots and re-render PDF/PPTX
</commit_message>
<xml_diff>
--- a/deck/Swasth_App_Design_5_Slides.pptx
+++ b/deck/Swasth_App_Design_5_Slides.pptx
@@ -3235,7 +3235,7 @@
       </p:sp>
       <p:pic>
         <p:nvPicPr>
-          <p:cNvPr id="4" name="Picture 3" descr="15_swasth_hero_mockup.png"/>
+          <p:cNvPr id="4" name="Picture 3" descr="pillar1_1_home_overview.png"/>
           <p:cNvPicPr>
             <a:picLocks noChangeAspect="1"/>
           </p:cNvPicPr>
@@ -3369,7 +3369,7 @@
       </p:sp>
       <p:pic>
         <p:nvPicPr>
-          <p:cNvPr id="4" name="Picture 3" descr="21_app_information_architecture_tree.png"/>
+          <p:cNvPr id="4" name="Picture 3" descr="pillar1_4_home_vitals.png"/>
           <p:cNvPicPr>
             <a:picLocks noChangeAspect="1"/>
           </p:cNvPicPr>
@@ -3393,7 +3393,7 @@
       </p:pic>
       <p:pic>
         <p:nvPicPr>
-          <p:cNvPr id="5" name="Picture 4" descr="28_feature_personalized_journey_intent.png"/>
+          <p:cNvPr id="5" name="Picture 4" descr="pillar1_3_home_milestones.png"/>
           <p:cNvPicPr>
             <a:picLocks noChangeAspect="1"/>
           </p:cNvPicPr>
@@ -3712,7 +3712,7 @@
       </p:sp>
       <p:pic>
         <p:nvPicPr>
-          <p:cNvPr id="4" name="Picture 3" descr="29_feature_due_date_estimation_methods.png"/>
+          <p:cNvPr id="4" name="Picture 3" descr="pillar2_1_plans_toolkit.png"/>
           <p:cNvPicPr>
             <a:picLocks noChangeAspect="1"/>
           </p:cNvPicPr>
@@ -3736,7 +3736,7 @@
       </p:pic>
       <p:pic>
         <p:nvPicPr>
-          <p:cNvPr id="5" name="Picture 4" descr="25_feature_baby_growth_tracking.png"/>
+          <p:cNvPr id="5" name="Picture 4" descr="pillar2_2_kick_counter.png"/>
           <p:cNvPicPr>
             <a:picLocks noChangeAspect="1"/>
           </p:cNvPicPr>
@@ -4025,7 +4025,7 @@
       </p:sp>
       <p:pic>
         <p:nvPicPr>
-          <p:cNvPr id="4" name="Picture 3" descr="30_feature_ai_pregnancy_assistant_chat.png"/>
+          <p:cNvPr id="4" name="Picture 3" descr="pillar4_2_timed_circuit.png"/>
           <p:cNvPicPr>
             <a:picLocks noChangeAspect="1"/>
           </p:cNvPicPr>
@@ -4049,7 +4049,7 @@
       </p:pic>
       <p:pic>
         <p:nvPicPr>
-          <p:cNvPr id="5" name="Picture 4" descr="swasth_app_design_preview.png"/>
+          <p:cNvPr id="5" name="Picture 4" descr="pillar4_4_nutrition_recipes.png"/>
           <p:cNvPicPr>
             <a:picLocks noChangeAspect="1"/>
           </p:cNvPicPr>
@@ -4338,7 +4338,7 @@
       </p:sp>
       <p:pic>
         <p:nvPicPr>
-          <p:cNvPr id="4" name="Picture 3" descr="31_feature_settings_preferences_data_protection.png"/>
+          <p:cNvPr id="4" name="Picture 3" descr="pillar5_2_abha_privacy.png"/>
           <p:cNvPicPr>
             <a:picLocks noChangeAspect="1"/>
           </p:cNvPicPr>

</xml_diff>